<commit_message>
Finalize public demo links and submission deck
</commit_message>
<xml_diff>
--- a/docs/Preflight_pitch_deck.pptx
+++ b/docs/Preflight_pitch_deck.pptx
@@ -9691,7 +9691,7 @@
                 <a:cs typeface="Google Sans Flex"/>
                 <a:sym typeface="Google Sans Flex"/>
               </a:rPr>
-              <a:t>Demo Video Link (3 Minutes)</a:t>
+              <a:t>Demo Video Link (3:28)</a:t>
             </a:r>
           </a:p>
           <a:p>
@@ -9707,14 +9707,15 @@
             <a:r>
               <a:rPr lang="en-US" sz="1500" b="0">
                 <a:solidFill>
-                  <a:srgbClr val="5F6368"/>
+                  <a:srgbClr val="202124"/>
                 </a:solidFill>
                 <a:latin typeface="Google Sans Flex"/>
                 <a:ea typeface="Google Sans Flex"/>
                 <a:cs typeface="Google Sans Flex"/>
                 <a:sym typeface="Google Sans Flex"/>
+                <a:hlinkClick r:id="rIdVideoFinal"/>
               </a:rPr>
-              <a:t>Pending public upload</a:t>
+              <a:t>https://youtu.be/nO-J4-5G-Gs</a:t>
             </a:r>
           </a:p>
           <a:p>
@@ -11251,6 +11252,29 @@
               <a:buNone/>
             </a:pPr>
             <a:r>
+              <a:rPr lang="en-US" sz="1400" b="0">
+                <a:solidFill>
+                  <a:srgbClr val="202124"/>
+                </a:solidFill>
+                <a:latin typeface="Google Sans Flex"/>
+                <a:ea typeface="Google Sans Flex"/>
+                <a:cs typeface="Google Sans Flex"/>
+                <a:sym typeface="Google Sans Flex"/>
+              </a:rPr>
+              <a:t>Business model: free risk check; paid API per check for studios, agencies and generator platforms.</a:t>
+            </a:r>
+          </a:p>
+          <a:p>
+            <a:pPr algn="l" marL="0" indent="0">
+              <a:lnSpc>
+                <a:spcPct val="108000"/>
+              </a:lnSpc>
+              <a:spcAft>
+                <a:spcPts val="600"/>
+              </a:spcAft>
+              <a:buNone/>
+            </a:pPr>
+            <a:r>
               <a:rPr lang="en-US" sz="1250" b="0">
                 <a:solidFill>
                   <a:srgbClr val="5F6368"/>
@@ -11825,104 +11849,6 @@
           </a:p>
         </p:txBody>
       </p:sp>
-      <p:sp>
-        <p:nvSpPr>
-          <p:cNvPr id="96" name="Generator loop"/>
-          <p:cNvSpPr txBox="1"/>
-          <p:nvPr/>
-        </p:nvSpPr>
-        <p:spPr>
-          <a:xfrm>
-            <a:off x="393192" y="1261872"/>
-            <a:ext cx="8321040" cy="420624"/>
-          </a:xfrm>
-          <a:prstGeom prst="rect">
-            <a:avLst/>
-          </a:prstGeom>
-          <a:noFill/>
-          <a:ln w="12700">
-            <a:noFill/>
-          </a:ln>
-        </p:spPr>
-        <p:txBody>
-          <a:bodyPr wrap="square" anchor="t" lIns="27432" rIns="27432" tIns="27432" bIns="27432">
-            <a:noAutofit/>
-          </a:bodyPr>
-          <a:lstStyle/>
-          <a:p>
-            <a:pPr algn="l" marL="0" indent="0">
-              <a:lnSpc>
-                <a:spcPct val="108000"/>
-              </a:lnSpc>
-              <a:spcAft>
-                <a:spcPts val="500"/>
-              </a:spcAft>
-              <a:buNone/>
-            </a:pPr>
-            <a:r>
-              <a:rPr lang="en-US" sz="1550" b="0">
-                <a:solidFill>
-                  <a:srgbClr val="202124"/>
-                </a:solidFill>
-                <a:latin typeface="Google Sans Flex Medium"/>
-                <a:ea typeface="Google Sans Flex Medium"/>
-                <a:cs typeface="Google Sans Flex Medium"/>
-                <a:sym typeface="Google Sans Flex Medium"/>
-              </a:rPr>
-              <a:t>Every generator's loop: prompt → pay → generate → judge → re-prompt.</a:t>
-            </a:r>
-          </a:p>
-        </p:txBody>
-      </p:sp>
-      <p:sp>
-        <p:nvSpPr>
-          <p:cNvPr id="97" name="Preflight placement"/>
-          <p:cNvSpPr txBox="1"/>
-          <p:nvPr/>
-        </p:nvSpPr>
-        <p:spPr>
-          <a:xfrm>
-            <a:off x="393192" y="1810512"/>
-            <a:ext cx="8321040" cy="530352"/>
-          </a:xfrm>
-          <a:prstGeom prst="rect">
-            <a:avLst/>
-          </a:prstGeom>
-          <a:noFill/>
-          <a:ln w="12700">
-            <a:noFill/>
-          </a:ln>
-        </p:spPr>
-        <p:txBody>
-          <a:bodyPr wrap="square" anchor="t" lIns="27432" rIns="27432" tIns="27432" bIns="27432">
-            <a:noAutofit/>
-          </a:bodyPr>
-          <a:lstStyle/>
-          <a:p>
-            <a:pPr algn="l" marL="0" indent="0">
-              <a:lnSpc>
-                <a:spcPct val="108000"/>
-              </a:lnSpc>
-              <a:spcAft>
-                <a:spcPts val="500"/>
-              </a:spcAft>
-              <a:buNone/>
-            </a:pPr>
-            <a:r>
-              <a:rPr lang="en-US" sz="1500" b="0">
-                <a:solidFill>
-                  <a:srgbClr val="202124"/>
-                </a:solidFill>
-                <a:latin typeface="Google Sans Flex"/>
-                <a:ea typeface="Google Sans Flex"/>
-                <a:cs typeface="Google Sans Flex"/>
-                <a:sym typeface="Google Sans Flex"/>
-              </a:rPr>
-              <a:t>Preflight adds a risk check, a lower-risk rewrite and a still before "pay".</a:t>
-            </a:r>
-          </a:p>
-        </p:txBody>
-      </p:sp>
       <p:pic>
         <p:nvPicPr>
           <p:cNvPr id="98" name="Saved original spoon/laptop still" descr="docs/deck_assets/spoon_original.jpg"/>
@@ -11937,8 +11863,8 @@
         </p:blipFill>
         <p:spPr>
           <a:xfrm>
-            <a:off x="429768" y="2468880"/>
-            <a:ext cx="3822192" cy="2184109"/>
+            <a:off x="1261872" y="3209544"/>
+            <a:ext cx="2514600" cy="1436914"/>
           </a:xfrm>
           <a:prstGeom prst="rect">
             <a:avLst/>
@@ -11959,8 +11885,8 @@
         </p:blipFill>
         <p:spPr>
           <a:xfrm>
-            <a:off x="4617720" y="2468880"/>
-            <a:ext cx="3822192" cy="2184109"/>
+            <a:off x="5367528" y="3209544"/>
+            <a:ext cx="2514600" cy="1436914"/>
           </a:xfrm>
           <a:prstGeom prst="rect">
             <a:avLst/>
@@ -11975,8 +11901,8 @@
         </p:nvSpPr>
         <p:spPr>
           <a:xfrm>
-            <a:off x="429768" y="4681728"/>
-            <a:ext cx="3822192" cy="219456"/>
+            <a:off x="1261872" y="4681728"/>
+            <a:ext cx="2514600" cy="219456"/>
           </a:xfrm>
           <a:prstGeom prst="rect">
             <a:avLst/>
@@ -12024,8 +11950,8 @@
         </p:nvSpPr>
         <p:spPr>
           <a:xfrm>
-            <a:off x="4617720" y="4681728"/>
-            <a:ext cx="3822192" cy="219456"/>
+            <a:off x="5367528" y="4681728"/>
+            <a:ext cx="2514600" cy="219456"/>
           </a:xfrm>
           <a:prstGeom prst="rect">
             <a:avLst/>
@@ -12061,6 +11987,1472 @@
                 <a:sym typeface="Google Sans Flex"/>
               </a:rPr>
               <a:t>Saved rewrite still</a:t>
+            </a:r>
+          </a:p>
+        </p:txBody>
+      </p:sp>
+      <p:cxnSp>
+        <p:nvCxnSpPr>
+          <p:cNvPr id="102" name="">
+            <a:extLst>
+              <a:ext uri="{FF2B5EF4-FFF2-40B4-BE49-F238E27FC236}">
+                <a16:creationId xmlns:a16="http://schemas.microsoft.com/office/drawing/2014/main" id="{75E45F29-E667-42B8-BF8D-C406F9960CAD}"/>
+              </a:ext>
+            </a:extLst>
+          </p:cNvPr>
+          <p:cNvCxnSpPr>
+            <a:stCxn id="111" idx="3"/>
+            <a:endCxn id="112" idx="1"/>
+          </p:cNvCxnSpPr>
+          <p:nvPr/>
+        </p:nvCxnSpPr>
+        <p:spPr>
+          <a:xfrm>
+            <a:off x="7260336" y="2039112"/>
+            <a:ext cx="201168" cy="0"/>
+          </a:xfrm>
+          <a:prstGeom prst="straightConnector1">
+            <a:avLst/>
+          </a:prstGeom>
+          <a:ln w="17000">
+            <a:solidFill>
+              <a:srgbClr val="5F6368"/>
+            </a:solidFill>
+            <a:prstDash val="solid"/>
+            <a:tailEnd type="triangle" w="med" len="med"/>
+          </a:ln>
+        </p:spPr>
+      </p:cxnSp>
+      <p:cxnSp>
+        <p:nvCxnSpPr>
+          <p:cNvPr id="103" name="">
+            <a:extLst>
+              <a:ext uri="{FF2B5EF4-FFF2-40B4-BE49-F238E27FC236}">
+                <a16:creationId xmlns:a16="http://schemas.microsoft.com/office/drawing/2014/main" id="{A6461C30-9F7F-4F0F-8CD4-D07BDEA24BE8}"/>
+              </a:ext>
+            </a:extLst>
+          </p:cNvPr>
+          <p:cNvCxnSpPr>
+            <a:stCxn id="110" idx="3"/>
+            <a:endCxn id="111" idx="1"/>
+          </p:cNvCxnSpPr>
+          <p:nvPr/>
+        </p:nvCxnSpPr>
+        <p:spPr>
+          <a:xfrm>
+            <a:off x="5870448" y="2039112"/>
+            <a:ext cx="201168" cy="0"/>
+          </a:xfrm>
+          <a:prstGeom prst="straightConnector1">
+            <a:avLst/>
+          </a:prstGeom>
+          <a:ln w="17000">
+            <a:solidFill>
+              <a:srgbClr val="5F6368"/>
+            </a:solidFill>
+            <a:prstDash val="solid"/>
+            <a:tailEnd type="triangle" w="med" len="med"/>
+          </a:ln>
+        </p:spPr>
+      </p:cxnSp>
+      <p:cxnSp>
+        <p:nvCxnSpPr>
+          <p:cNvPr id="104" name="">
+            <a:extLst>
+              <a:ext uri="{FF2B5EF4-FFF2-40B4-BE49-F238E27FC236}">
+                <a16:creationId xmlns:a16="http://schemas.microsoft.com/office/drawing/2014/main" id="{02FCE439-EA48-4E97-8143-4A154C2F7929}"/>
+              </a:ext>
+            </a:extLst>
+          </p:cNvPr>
+          <p:cNvCxnSpPr>
+            <a:stCxn id="109" idx="3"/>
+            <a:endCxn id="110" idx="1"/>
+          </p:cNvCxnSpPr>
+          <p:nvPr/>
+        </p:nvCxnSpPr>
+        <p:spPr>
+          <a:xfrm>
+            <a:off x="4526280" y="2039112"/>
+            <a:ext cx="201168" cy="0"/>
+          </a:xfrm>
+          <a:prstGeom prst="straightConnector1">
+            <a:avLst/>
+          </a:prstGeom>
+          <a:ln w="17000">
+            <a:solidFill>
+              <a:srgbClr val="5F6368"/>
+            </a:solidFill>
+            <a:prstDash val="solid"/>
+            <a:tailEnd type="triangle" w="med" len="med"/>
+          </a:ln>
+        </p:spPr>
+      </p:cxnSp>
+      <p:cxnSp>
+        <p:nvCxnSpPr>
+          <p:cNvPr id="105" name="">
+            <a:extLst>
+              <a:ext uri="{FF2B5EF4-FFF2-40B4-BE49-F238E27FC236}">
+                <a16:creationId xmlns:a16="http://schemas.microsoft.com/office/drawing/2014/main" id="{884299F8-B99F-4F51-BF05-FE2A8F0F8AF0}"/>
+              </a:ext>
+            </a:extLst>
+          </p:cNvPr>
+          <p:cNvCxnSpPr>
+            <a:stCxn id="108" idx="3"/>
+            <a:endCxn id="109" idx="1"/>
+          </p:cNvCxnSpPr>
+          <p:nvPr/>
+        </p:nvCxnSpPr>
+        <p:spPr>
+          <a:xfrm>
+            <a:off x="2587752" y="2039112"/>
+            <a:ext cx="201168" cy="0"/>
+          </a:xfrm>
+          <a:prstGeom prst="straightConnector1">
+            <a:avLst/>
+          </a:prstGeom>
+          <a:ln w="17000">
+            <a:solidFill>
+              <a:srgbClr val="5F6368"/>
+            </a:solidFill>
+            <a:prstDash val="solid"/>
+            <a:tailEnd type="triangle" w="med" len="med"/>
+          </a:ln>
+        </p:spPr>
+      </p:cxnSp>
+      <p:cxnSp>
+        <p:nvCxnSpPr>
+          <p:cNvPr id="106" name="">
+            <a:extLst>
+              <a:ext uri="{FF2B5EF4-FFF2-40B4-BE49-F238E27FC236}">
+                <a16:creationId xmlns:a16="http://schemas.microsoft.com/office/drawing/2014/main" id="{7ED53E77-91B3-4FF4-A7D6-8D16EB7218DF}"/>
+              </a:ext>
+            </a:extLst>
+          </p:cNvPr>
+          <p:cNvCxnSpPr>
+            <a:stCxn id="107" idx="3"/>
+            <a:endCxn id="108" idx="1"/>
+          </p:cNvCxnSpPr>
+          <p:nvPr/>
+        </p:nvCxnSpPr>
+        <p:spPr>
+          <a:xfrm>
+            <a:off x="1261872" y="2039112"/>
+            <a:ext cx="201168" cy="0"/>
+          </a:xfrm>
+          <a:prstGeom prst="straightConnector1">
+            <a:avLst/>
+          </a:prstGeom>
+          <a:ln w="17000">
+            <a:solidFill>
+              <a:srgbClr val="5F6368"/>
+            </a:solidFill>
+            <a:prstDash val="solid"/>
+            <a:tailEnd type="triangle" w="med" len="med"/>
+          </a:ln>
+        </p:spPr>
+      </p:cxnSp>
+      <p:sp>
+        <p:nvSpPr>
+          <p:cNvPr id="107" name="Gprime flow 1: Prompt">
+            <a:extLst>
+              <a:ext uri="{FF2B5EF4-FFF2-40B4-BE49-F238E27FC236}">
+                <a16:creationId xmlns:a16="http://schemas.microsoft.com/office/drawing/2014/main" id="{477F5E5D-847B-4DB3-9C4D-ABAD41EAE159}"/>
+              </a:ext>
+            </a:extLst>
+          </p:cNvPr>
+          <p:cNvSpPr>
+            <a:spLocks noGrp="1"/>
+          </p:cNvSpPr>
+          <p:nvPr/>
+        </p:nvSpPr>
+        <p:spPr>
+          <a:xfrm>
+            <a:off x="393192" y="1572768"/>
+            <a:ext cx="868680" cy="932688"/>
+          </a:xfrm>
+          <a:prstGeom prst="rect">
+            <a:avLst/>
+          </a:prstGeom>
+          <a:solidFill>
+            <a:srgbClr val="F8F9FA"/>
+          </a:solidFill>
+          <a:ln w="12700">
+            <a:solidFill>
+              <a:srgbClr val="BDC1C6"/>
+            </a:solidFill>
+            <a:prstDash val="solid"/>
+          </a:ln>
+        </p:spPr>
+        <p:txBody>
+          <a:bodyPr lIns="38100" tIns="57150" rIns="38100" bIns="57150" anchor="ctr"/>
+          <a:lstStyle>
+            <a:defPPr algn="ctr">
+              <a:defRPr sz="1200">
+                <a:solidFill>
+                  <a:srgbClr val="202124"/>
+                </a:solidFill>
+                <a:latin typeface="Google Sans Flex"/>
+                <a:ea typeface="Google Sans Flex"/>
+                <a:cs typeface="Google Sans Flex"/>
+              </a:defRPr>
+            </a:defPPr>
+            <a:lvl1pPr algn="ctr">
+              <a:defRPr sz="1200">
+                <a:solidFill>
+                  <a:srgbClr val="202124"/>
+                </a:solidFill>
+                <a:latin typeface="Google Sans Flex"/>
+                <a:ea typeface="Google Sans Flex"/>
+                <a:cs typeface="Google Sans Flex"/>
+              </a:defRPr>
+            </a:lvl1pPr>
+            <a:lvl2pPr algn="ctr">
+              <a:defRPr sz="1200">
+                <a:solidFill>
+                  <a:srgbClr val="202124"/>
+                </a:solidFill>
+                <a:latin typeface="Google Sans Flex"/>
+                <a:ea typeface="Google Sans Flex"/>
+                <a:cs typeface="Google Sans Flex"/>
+              </a:defRPr>
+            </a:lvl2pPr>
+            <a:lvl3pPr algn="ctr">
+              <a:defRPr sz="1200">
+                <a:solidFill>
+                  <a:srgbClr val="202124"/>
+                </a:solidFill>
+                <a:latin typeface="Google Sans Flex"/>
+                <a:ea typeface="Google Sans Flex"/>
+                <a:cs typeface="Google Sans Flex"/>
+              </a:defRPr>
+            </a:lvl3pPr>
+            <a:lvl4pPr algn="ctr">
+              <a:defRPr sz="1200">
+                <a:solidFill>
+                  <a:srgbClr val="202124"/>
+                </a:solidFill>
+                <a:latin typeface="Google Sans Flex"/>
+                <a:ea typeface="Google Sans Flex"/>
+                <a:cs typeface="Google Sans Flex"/>
+              </a:defRPr>
+            </a:lvl4pPr>
+            <a:lvl5pPr algn="ctr">
+              <a:defRPr sz="1200">
+                <a:solidFill>
+                  <a:srgbClr val="202124"/>
+                </a:solidFill>
+                <a:latin typeface="Google Sans Flex"/>
+                <a:ea typeface="Google Sans Flex"/>
+                <a:cs typeface="Google Sans Flex"/>
+              </a:defRPr>
+            </a:lvl5pPr>
+            <a:lvl6pPr algn="ctr">
+              <a:defRPr sz="1200">
+                <a:solidFill>
+                  <a:srgbClr val="202124"/>
+                </a:solidFill>
+                <a:latin typeface="Google Sans Flex"/>
+                <a:ea typeface="Google Sans Flex"/>
+                <a:cs typeface="Google Sans Flex"/>
+              </a:defRPr>
+            </a:lvl6pPr>
+            <a:lvl7pPr algn="ctr">
+              <a:defRPr sz="1200">
+                <a:solidFill>
+                  <a:srgbClr val="202124"/>
+                </a:solidFill>
+                <a:latin typeface="Google Sans Flex"/>
+                <a:ea typeface="Google Sans Flex"/>
+                <a:cs typeface="Google Sans Flex"/>
+              </a:defRPr>
+            </a:lvl7pPr>
+            <a:lvl8pPr algn="ctr">
+              <a:defRPr sz="1200">
+                <a:solidFill>
+                  <a:srgbClr val="202124"/>
+                </a:solidFill>
+                <a:latin typeface="Google Sans Flex"/>
+                <a:ea typeface="Google Sans Flex"/>
+                <a:cs typeface="Google Sans Flex"/>
+              </a:defRPr>
+            </a:lvl8pPr>
+            <a:lvl9pPr algn="ctr">
+              <a:defRPr sz="1200">
+                <a:solidFill>
+                  <a:srgbClr val="202124"/>
+                </a:solidFill>
+                <a:latin typeface="Google Sans Flex"/>
+                <a:ea typeface="Google Sans Flex"/>
+                <a:cs typeface="Google Sans Flex"/>
+              </a:defRPr>
+            </a:lvl9pPr>
+          </a:lstStyle>
+          <a:p>
+            <a:pPr algn="ctr">
+              <a:defRPr sz="1200">
+                <a:solidFill>
+                  <a:srgbClr val="202124"/>
+                </a:solidFill>
+                <a:latin typeface="Google Sans Flex"/>
+                <a:ea typeface="Google Sans Flex"/>
+                <a:cs typeface="Google Sans Flex"/>
+              </a:defRPr>
+            </a:pPr>
+            <a:r>
+              <a:rPr sz="1200">
+                <a:solidFill>
+                  <a:srgbClr val="202124"/>
+                </a:solidFill>
+                <a:latin typeface="Google Sans Flex"/>
+                <a:ea typeface="Google Sans Flex"/>
+                <a:cs typeface="Google Sans Flex"/>
+              </a:rPr>
+              <a:t>Prompt</a:t>
+            </a:r>
+          </a:p>
+        </p:txBody>
+      </p:sp>
+      <p:sp>
+        <p:nvSpPr>
+          <p:cNvPr id="108" name="Gprime flow 2: Risk check (free)">
+            <a:extLst>
+              <a:ext uri="{FF2B5EF4-FFF2-40B4-BE49-F238E27FC236}">
+                <a16:creationId xmlns:a16="http://schemas.microsoft.com/office/drawing/2014/main" id="{0408BA69-9700-462A-8031-7C3B4FEB88E5}"/>
+              </a:ext>
+            </a:extLst>
+          </p:cNvPr>
+          <p:cNvSpPr>
+            <a:spLocks noGrp="1"/>
+          </p:cNvSpPr>
+          <p:nvPr/>
+        </p:nvSpPr>
+        <p:spPr>
+          <a:xfrm>
+            <a:off x="1463040" y="1572768"/>
+            <a:ext cx="1124712" cy="932688"/>
+          </a:xfrm>
+          <a:prstGeom prst="rect">
+            <a:avLst/>
+          </a:prstGeom>
+          <a:solidFill>
+            <a:srgbClr val="F8F9FA"/>
+          </a:solidFill>
+          <a:ln w="12700">
+            <a:solidFill>
+              <a:srgbClr val="BDC1C6"/>
+            </a:solidFill>
+            <a:prstDash val="solid"/>
+          </a:ln>
+        </p:spPr>
+        <p:txBody>
+          <a:bodyPr lIns="38100" tIns="57150" rIns="38100" bIns="57150" anchor="ctr"/>
+          <a:lstStyle>
+            <a:defPPr algn="ctr">
+              <a:defRPr sz="1200">
+                <a:solidFill>
+                  <a:srgbClr val="202124"/>
+                </a:solidFill>
+                <a:latin typeface="Google Sans Flex"/>
+                <a:ea typeface="Google Sans Flex"/>
+                <a:cs typeface="Google Sans Flex"/>
+              </a:defRPr>
+            </a:defPPr>
+            <a:lvl1pPr algn="ctr">
+              <a:defRPr sz="1200">
+                <a:solidFill>
+                  <a:srgbClr val="202124"/>
+                </a:solidFill>
+                <a:latin typeface="Google Sans Flex"/>
+                <a:ea typeface="Google Sans Flex"/>
+                <a:cs typeface="Google Sans Flex"/>
+              </a:defRPr>
+            </a:lvl1pPr>
+            <a:lvl2pPr algn="ctr">
+              <a:defRPr sz="1200">
+                <a:solidFill>
+                  <a:srgbClr val="202124"/>
+                </a:solidFill>
+                <a:latin typeface="Google Sans Flex"/>
+                <a:ea typeface="Google Sans Flex"/>
+                <a:cs typeface="Google Sans Flex"/>
+              </a:defRPr>
+            </a:lvl2pPr>
+            <a:lvl3pPr algn="ctr">
+              <a:defRPr sz="1200">
+                <a:solidFill>
+                  <a:srgbClr val="202124"/>
+                </a:solidFill>
+                <a:latin typeface="Google Sans Flex"/>
+                <a:ea typeface="Google Sans Flex"/>
+                <a:cs typeface="Google Sans Flex"/>
+              </a:defRPr>
+            </a:lvl3pPr>
+            <a:lvl4pPr algn="ctr">
+              <a:defRPr sz="1200">
+                <a:solidFill>
+                  <a:srgbClr val="202124"/>
+                </a:solidFill>
+                <a:latin typeface="Google Sans Flex"/>
+                <a:ea typeface="Google Sans Flex"/>
+                <a:cs typeface="Google Sans Flex"/>
+              </a:defRPr>
+            </a:lvl4pPr>
+            <a:lvl5pPr algn="ctr">
+              <a:defRPr sz="1200">
+                <a:solidFill>
+                  <a:srgbClr val="202124"/>
+                </a:solidFill>
+                <a:latin typeface="Google Sans Flex"/>
+                <a:ea typeface="Google Sans Flex"/>
+                <a:cs typeface="Google Sans Flex"/>
+              </a:defRPr>
+            </a:lvl5pPr>
+            <a:lvl6pPr algn="ctr">
+              <a:defRPr sz="1200">
+                <a:solidFill>
+                  <a:srgbClr val="202124"/>
+                </a:solidFill>
+                <a:latin typeface="Google Sans Flex"/>
+                <a:ea typeface="Google Sans Flex"/>
+                <a:cs typeface="Google Sans Flex"/>
+              </a:defRPr>
+            </a:lvl6pPr>
+            <a:lvl7pPr algn="ctr">
+              <a:defRPr sz="1200">
+                <a:solidFill>
+                  <a:srgbClr val="202124"/>
+                </a:solidFill>
+                <a:latin typeface="Google Sans Flex"/>
+                <a:ea typeface="Google Sans Flex"/>
+                <a:cs typeface="Google Sans Flex"/>
+              </a:defRPr>
+            </a:lvl7pPr>
+            <a:lvl8pPr algn="ctr">
+              <a:defRPr sz="1200">
+                <a:solidFill>
+                  <a:srgbClr val="202124"/>
+                </a:solidFill>
+                <a:latin typeface="Google Sans Flex"/>
+                <a:ea typeface="Google Sans Flex"/>
+                <a:cs typeface="Google Sans Flex"/>
+              </a:defRPr>
+            </a:lvl8pPr>
+            <a:lvl9pPr algn="ctr">
+              <a:defRPr sz="1200">
+                <a:solidFill>
+                  <a:srgbClr val="202124"/>
+                </a:solidFill>
+                <a:latin typeface="Google Sans Flex"/>
+                <a:ea typeface="Google Sans Flex"/>
+                <a:cs typeface="Google Sans Flex"/>
+              </a:defRPr>
+            </a:lvl9pPr>
+          </a:lstStyle>
+          <a:p>
+            <a:pPr algn="ctr">
+              <a:defRPr sz="1200">
+                <a:solidFill>
+                  <a:srgbClr val="202124"/>
+                </a:solidFill>
+                <a:latin typeface="Google Sans Flex"/>
+                <a:ea typeface="Google Sans Flex"/>
+                <a:cs typeface="Google Sans Flex"/>
+              </a:defRPr>
+            </a:pPr>
+            <a:r>
+              <a:rPr sz="1200">
+                <a:solidFill>
+                  <a:srgbClr val="202124"/>
+                </a:solidFill>
+                <a:latin typeface="Google Sans Flex"/>
+                <a:ea typeface="Google Sans Flex"/>
+                <a:cs typeface="Google Sans Flex"/>
+              </a:rPr>
+              <a:t>Risk check</a:t>
+            </a:r>
+          </a:p>
+          <a:p>
+            <a:pPr algn="ctr">
+              <a:defRPr sz="1200">
+                <a:solidFill>
+                  <a:srgbClr val="202124"/>
+                </a:solidFill>
+                <a:latin typeface="Google Sans Flex"/>
+                <a:ea typeface="Google Sans Flex"/>
+                <a:cs typeface="Google Sans Flex"/>
+              </a:defRPr>
+            </a:pPr>
+            <a:r>
+              <a:rPr sz="1200">
+                <a:solidFill>
+                  <a:srgbClr val="202124"/>
+                </a:solidFill>
+                <a:latin typeface="Google Sans Flex"/>
+                <a:ea typeface="Google Sans Flex"/>
+                <a:cs typeface="Google Sans Flex"/>
+              </a:rPr>
+              <a:t>(free)</a:t>
+            </a:r>
+          </a:p>
+        </p:txBody>
+      </p:sp>
+      <p:sp>
+        <p:nvSpPr>
+          <p:cNvPr id="109" name="Gprime flow 3: Gemini rewrite (kept only if risk drops)">
+            <a:extLst>
+              <a:ext uri="{FF2B5EF4-FFF2-40B4-BE49-F238E27FC236}">
+                <a16:creationId xmlns:a16="http://schemas.microsoft.com/office/drawing/2014/main" id="{52222CDD-70F0-43C1-9D75-AE59A1448527}"/>
+              </a:ext>
+            </a:extLst>
+          </p:cNvPr>
+          <p:cNvSpPr>
+            <a:spLocks noGrp="1"/>
+          </p:cNvSpPr>
+          <p:nvPr/>
+        </p:nvSpPr>
+        <p:spPr>
+          <a:xfrm>
+            <a:off x="2788920" y="1572768"/>
+            <a:ext cx="1737360" cy="932688"/>
+          </a:xfrm>
+          <a:prstGeom prst="rect">
+            <a:avLst/>
+          </a:prstGeom>
+          <a:solidFill>
+            <a:srgbClr val="F8F9FA"/>
+          </a:solidFill>
+          <a:ln w="12700">
+            <a:solidFill>
+              <a:srgbClr val="BDC1C6"/>
+            </a:solidFill>
+            <a:prstDash val="solid"/>
+          </a:ln>
+        </p:spPr>
+        <p:txBody>
+          <a:bodyPr lIns="38100" tIns="57150" rIns="38100" bIns="57150" anchor="ctr"/>
+          <a:lstStyle>
+            <a:defPPr algn="ctr">
+              <a:defRPr sz="1200">
+                <a:solidFill>
+                  <a:srgbClr val="202124"/>
+                </a:solidFill>
+                <a:latin typeface="Google Sans Flex"/>
+                <a:ea typeface="Google Sans Flex"/>
+                <a:cs typeface="Google Sans Flex"/>
+              </a:defRPr>
+            </a:defPPr>
+            <a:lvl1pPr algn="ctr">
+              <a:defRPr sz="1200">
+                <a:solidFill>
+                  <a:srgbClr val="202124"/>
+                </a:solidFill>
+                <a:latin typeface="Google Sans Flex"/>
+                <a:ea typeface="Google Sans Flex"/>
+                <a:cs typeface="Google Sans Flex"/>
+              </a:defRPr>
+            </a:lvl1pPr>
+            <a:lvl2pPr algn="ctr">
+              <a:defRPr sz="1200">
+                <a:solidFill>
+                  <a:srgbClr val="202124"/>
+                </a:solidFill>
+                <a:latin typeface="Google Sans Flex"/>
+                <a:ea typeface="Google Sans Flex"/>
+                <a:cs typeface="Google Sans Flex"/>
+              </a:defRPr>
+            </a:lvl2pPr>
+            <a:lvl3pPr algn="ctr">
+              <a:defRPr sz="1200">
+                <a:solidFill>
+                  <a:srgbClr val="202124"/>
+                </a:solidFill>
+                <a:latin typeface="Google Sans Flex"/>
+                <a:ea typeface="Google Sans Flex"/>
+                <a:cs typeface="Google Sans Flex"/>
+              </a:defRPr>
+            </a:lvl3pPr>
+            <a:lvl4pPr algn="ctr">
+              <a:defRPr sz="1200">
+                <a:solidFill>
+                  <a:srgbClr val="202124"/>
+                </a:solidFill>
+                <a:latin typeface="Google Sans Flex"/>
+                <a:ea typeface="Google Sans Flex"/>
+                <a:cs typeface="Google Sans Flex"/>
+              </a:defRPr>
+            </a:lvl4pPr>
+            <a:lvl5pPr algn="ctr">
+              <a:defRPr sz="1200">
+                <a:solidFill>
+                  <a:srgbClr val="202124"/>
+                </a:solidFill>
+                <a:latin typeface="Google Sans Flex"/>
+                <a:ea typeface="Google Sans Flex"/>
+                <a:cs typeface="Google Sans Flex"/>
+              </a:defRPr>
+            </a:lvl5pPr>
+            <a:lvl6pPr algn="ctr">
+              <a:defRPr sz="1200">
+                <a:solidFill>
+                  <a:srgbClr val="202124"/>
+                </a:solidFill>
+                <a:latin typeface="Google Sans Flex"/>
+                <a:ea typeface="Google Sans Flex"/>
+                <a:cs typeface="Google Sans Flex"/>
+              </a:defRPr>
+            </a:lvl6pPr>
+            <a:lvl7pPr algn="ctr">
+              <a:defRPr sz="1200">
+                <a:solidFill>
+                  <a:srgbClr val="202124"/>
+                </a:solidFill>
+                <a:latin typeface="Google Sans Flex"/>
+                <a:ea typeface="Google Sans Flex"/>
+                <a:cs typeface="Google Sans Flex"/>
+              </a:defRPr>
+            </a:lvl7pPr>
+            <a:lvl8pPr algn="ctr">
+              <a:defRPr sz="1200">
+                <a:solidFill>
+                  <a:srgbClr val="202124"/>
+                </a:solidFill>
+                <a:latin typeface="Google Sans Flex"/>
+                <a:ea typeface="Google Sans Flex"/>
+                <a:cs typeface="Google Sans Flex"/>
+              </a:defRPr>
+            </a:lvl8pPr>
+            <a:lvl9pPr algn="ctr">
+              <a:defRPr sz="1200">
+                <a:solidFill>
+                  <a:srgbClr val="202124"/>
+                </a:solidFill>
+                <a:latin typeface="Google Sans Flex"/>
+                <a:ea typeface="Google Sans Flex"/>
+                <a:cs typeface="Google Sans Flex"/>
+              </a:defRPr>
+            </a:lvl9pPr>
+          </a:lstStyle>
+          <a:p>
+            <a:pPr algn="ctr">
+              <a:defRPr sz="1200">
+                <a:solidFill>
+                  <a:srgbClr val="202124"/>
+                </a:solidFill>
+                <a:latin typeface="Google Sans Flex"/>
+                <a:ea typeface="Google Sans Flex"/>
+                <a:cs typeface="Google Sans Flex"/>
+              </a:defRPr>
+            </a:pPr>
+            <a:r>
+              <a:rPr sz="1200">
+                <a:solidFill>
+                  <a:srgbClr val="202124"/>
+                </a:solidFill>
+                <a:latin typeface="Google Sans Flex"/>
+                <a:ea typeface="Google Sans Flex"/>
+                <a:cs typeface="Google Sans Flex"/>
+              </a:rPr>
+              <a:t>Gemini rewrite</a:t>
+            </a:r>
+          </a:p>
+          <a:p>
+            <a:pPr algn="ctr">
+              <a:defRPr sz="1200">
+                <a:solidFill>
+                  <a:srgbClr val="202124"/>
+                </a:solidFill>
+                <a:latin typeface="Google Sans Flex"/>
+                <a:ea typeface="Google Sans Flex"/>
+                <a:cs typeface="Google Sans Flex"/>
+              </a:defRPr>
+            </a:pPr>
+            <a:r>
+              <a:rPr sz="1200">
+                <a:solidFill>
+                  <a:srgbClr val="202124"/>
+                </a:solidFill>
+                <a:latin typeface="Google Sans Flex"/>
+                <a:ea typeface="Google Sans Flex"/>
+                <a:cs typeface="Google Sans Flex"/>
+              </a:rPr>
+              <a:t>(kept only if</a:t>
+            </a:r>
+          </a:p>
+          <a:p>
+            <a:pPr algn="ctr">
+              <a:defRPr sz="1200">
+                <a:solidFill>
+                  <a:srgbClr val="202124"/>
+                </a:solidFill>
+                <a:latin typeface="Google Sans Flex"/>
+                <a:ea typeface="Google Sans Flex"/>
+                <a:cs typeface="Google Sans Flex"/>
+              </a:defRPr>
+            </a:pPr>
+            <a:r>
+              <a:rPr sz="1200">
+                <a:solidFill>
+                  <a:srgbClr val="202124"/>
+                </a:solidFill>
+                <a:latin typeface="Google Sans Flex"/>
+                <a:ea typeface="Google Sans Flex"/>
+                <a:cs typeface="Google Sans Flex"/>
+              </a:rPr>
+              <a:t>risk drops)</a:t>
+            </a:r>
+          </a:p>
+        </p:txBody>
+      </p:sp>
+      <p:sp>
+        <p:nvSpPr>
+          <p:cNvPr id="110" name="Gprime flow 4: Still preview">
+            <a:extLst>
+              <a:ext uri="{FF2B5EF4-FFF2-40B4-BE49-F238E27FC236}">
+                <a16:creationId xmlns:a16="http://schemas.microsoft.com/office/drawing/2014/main" id="{E3992291-8768-4984-B8A1-784B78030A8E}"/>
+              </a:ext>
+            </a:extLst>
+          </p:cNvPr>
+          <p:cNvSpPr>
+            <a:spLocks noGrp="1"/>
+          </p:cNvSpPr>
+          <p:nvPr/>
+        </p:nvSpPr>
+        <p:spPr>
+          <a:xfrm>
+            <a:off x="4727448" y="1572768"/>
+            <a:ext cx="1143000" cy="932688"/>
+          </a:xfrm>
+          <a:prstGeom prst="rect">
+            <a:avLst/>
+          </a:prstGeom>
+          <a:solidFill>
+            <a:srgbClr val="F8F9FA"/>
+          </a:solidFill>
+          <a:ln w="12700">
+            <a:solidFill>
+              <a:srgbClr val="BDC1C6"/>
+            </a:solidFill>
+            <a:prstDash val="solid"/>
+          </a:ln>
+        </p:spPr>
+        <p:txBody>
+          <a:bodyPr lIns="38100" tIns="57150" rIns="38100" bIns="57150" anchor="ctr"/>
+          <a:lstStyle>
+            <a:defPPr algn="ctr">
+              <a:defRPr sz="1200">
+                <a:solidFill>
+                  <a:srgbClr val="202124"/>
+                </a:solidFill>
+                <a:latin typeface="Google Sans Flex"/>
+                <a:ea typeface="Google Sans Flex"/>
+                <a:cs typeface="Google Sans Flex"/>
+              </a:defRPr>
+            </a:defPPr>
+            <a:lvl1pPr algn="ctr">
+              <a:defRPr sz="1200">
+                <a:solidFill>
+                  <a:srgbClr val="202124"/>
+                </a:solidFill>
+                <a:latin typeface="Google Sans Flex"/>
+                <a:ea typeface="Google Sans Flex"/>
+                <a:cs typeface="Google Sans Flex"/>
+              </a:defRPr>
+            </a:lvl1pPr>
+            <a:lvl2pPr algn="ctr">
+              <a:defRPr sz="1200">
+                <a:solidFill>
+                  <a:srgbClr val="202124"/>
+                </a:solidFill>
+                <a:latin typeface="Google Sans Flex"/>
+                <a:ea typeface="Google Sans Flex"/>
+                <a:cs typeface="Google Sans Flex"/>
+              </a:defRPr>
+            </a:lvl2pPr>
+            <a:lvl3pPr algn="ctr">
+              <a:defRPr sz="1200">
+                <a:solidFill>
+                  <a:srgbClr val="202124"/>
+                </a:solidFill>
+                <a:latin typeface="Google Sans Flex"/>
+                <a:ea typeface="Google Sans Flex"/>
+                <a:cs typeface="Google Sans Flex"/>
+              </a:defRPr>
+            </a:lvl3pPr>
+            <a:lvl4pPr algn="ctr">
+              <a:defRPr sz="1200">
+                <a:solidFill>
+                  <a:srgbClr val="202124"/>
+                </a:solidFill>
+                <a:latin typeface="Google Sans Flex"/>
+                <a:ea typeface="Google Sans Flex"/>
+                <a:cs typeface="Google Sans Flex"/>
+              </a:defRPr>
+            </a:lvl4pPr>
+            <a:lvl5pPr algn="ctr">
+              <a:defRPr sz="1200">
+                <a:solidFill>
+                  <a:srgbClr val="202124"/>
+                </a:solidFill>
+                <a:latin typeface="Google Sans Flex"/>
+                <a:ea typeface="Google Sans Flex"/>
+                <a:cs typeface="Google Sans Flex"/>
+              </a:defRPr>
+            </a:lvl5pPr>
+            <a:lvl6pPr algn="ctr">
+              <a:defRPr sz="1200">
+                <a:solidFill>
+                  <a:srgbClr val="202124"/>
+                </a:solidFill>
+                <a:latin typeface="Google Sans Flex"/>
+                <a:ea typeface="Google Sans Flex"/>
+                <a:cs typeface="Google Sans Flex"/>
+              </a:defRPr>
+            </a:lvl6pPr>
+            <a:lvl7pPr algn="ctr">
+              <a:defRPr sz="1200">
+                <a:solidFill>
+                  <a:srgbClr val="202124"/>
+                </a:solidFill>
+                <a:latin typeface="Google Sans Flex"/>
+                <a:ea typeface="Google Sans Flex"/>
+                <a:cs typeface="Google Sans Flex"/>
+              </a:defRPr>
+            </a:lvl7pPr>
+            <a:lvl8pPr algn="ctr">
+              <a:defRPr sz="1200">
+                <a:solidFill>
+                  <a:srgbClr val="202124"/>
+                </a:solidFill>
+                <a:latin typeface="Google Sans Flex"/>
+                <a:ea typeface="Google Sans Flex"/>
+                <a:cs typeface="Google Sans Flex"/>
+              </a:defRPr>
+            </a:lvl8pPr>
+            <a:lvl9pPr algn="ctr">
+              <a:defRPr sz="1200">
+                <a:solidFill>
+                  <a:srgbClr val="202124"/>
+                </a:solidFill>
+                <a:latin typeface="Google Sans Flex"/>
+                <a:ea typeface="Google Sans Flex"/>
+                <a:cs typeface="Google Sans Flex"/>
+              </a:defRPr>
+            </a:lvl9pPr>
+          </a:lstStyle>
+          <a:p>
+            <a:pPr algn="ctr">
+              <a:defRPr sz="1200">
+                <a:solidFill>
+                  <a:srgbClr val="202124"/>
+                </a:solidFill>
+                <a:latin typeface="Google Sans Flex"/>
+                <a:ea typeface="Google Sans Flex"/>
+                <a:cs typeface="Google Sans Flex"/>
+              </a:defRPr>
+            </a:pPr>
+            <a:r>
+              <a:rPr sz="1200">
+                <a:solidFill>
+                  <a:srgbClr val="202124"/>
+                </a:solidFill>
+                <a:latin typeface="Google Sans Flex"/>
+                <a:ea typeface="Google Sans Flex"/>
+                <a:cs typeface="Google Sans Flex"/>
+              </a:rPr>
+              <a:t>Still</a:t>
+            </a:r>
+          </a:p>
+          <a:p>
+            <a:pPr algn="ctr">
+              <a:defRPr sz="1200">
+                <a:solidFill>
+                  <a:srgbClr val="202124"/>
+                </a:solidFill>
+                <a:latin typeface="Google Sans Flex"/>
+                <a:ea typeface="Google Sans Flex"/>
+                <a:cs typeface="Google Sans Flex"/>
+              </a:defRPr>
+            </a:pPr>
+            <a:r>
+              <a:rPr sz="1200">
+                <a:solidFill>
+                  <a:srgbClr val="202124"/>
+                </a:solidFill>
+                <a:latin typeface="Google Sans Flex"/>
+                <a:ea typeface="Google Sans Flex"/>
+                <a:cs typeface="Google Sans Flex"/>
+              </a:rPr>
+              <a:t>preview</a:t>
+            </a:r>
+          </a:p>
+        </p:txBody>
+      </p:sp>
+      <p:sp>
+        <p:nvSpPr>
+          <p:cNvPr id="111" name="Gprime flow 5: Pay &amp; generate">
+            <a:extLst>
+              <a:ext uri="{FF2B5EF4-FFF2-40B4-BE49-F238E27FC236}">
+                <a16:creationId xmlns:a16="http://schemas.microsoft.com/office/drawing/2014/main" id="{34C9A621-25D4-406E-9938-8D5B27A087FE}"/>
+              </a:ext>
+            </a:extLst>
+          </p:cNvPr>
+          <p:cNvSpPr>
+            <a:spLocks noGrp="1"/>
+          </p:cNvSpPr>
+          <p:nvPr/>
+        </p:nvSpPr>
+        <p:spPr>
+          <a:xfrm>
+            <a:off x="6071616" y="1572768"/>
+            <a:ext cx="1188720" cy="932688"/>
+          </a:xfrm>
+          <a:prstGeom prst="rect">
+            <a:avLst/>
+          </a:prstGeom>
+          <a:solidFill>
+            <a:srgbClr val="F8F9FA"/>
+          </a:solidFill>
+          <a:ln w="12700">
+            <a:solidFill>
+              <a:srgbClr val="BDC1C6"/>
+            </a:solidFill>
+            <a:prstDash val="solid"/>
+          </a:ln>
+        </p:spPr>
+        <p:txBody>
+          <a:bodyPr lIns="38100" tIns="57150" rIns="38100" bIns="57150" anchor="ctr"/>
+          <a:lstStyle>
+            <a:defPPr algn="ctr">
+              <a:defRPr sz="1200">
+                <a:solidFill>
+                  <a:srgbClr val="202124"/>
+                </a:solidFill>
+                <a:latin typeface="Google Sans Flex"/>
+                <a:ea typeface="Google Sans Flex"/>
+                <a:cs typeface="Google Sans Flex"/>
+              </a:defRPr>
+            </a:defPPr>
+            <a:lvl1pPr algn="ctr">
+              <a:defRPr sz="1200">
+                <a:solidFill>
+                  <a:srgbClr val="202124"/>
+                </a:solidFill>
+                <a:latin typeface="Google Sans Flex"/>
+                <a:ea typeface="Google Sans Flex"/>
+                <a:cs typeface="Google Sans Flex"/>
+              </a:defRPr>
+            </a:lvl1pPr>
+            <a:lvl2pPr algn="ctr">
+              <a:defRPr sz="1200">
+                <a:solidFill>
+                  <a:srgbClr val="202124"/>
+                </a:solidFill>
+                <a:latin typeface="Google Sans Flex"/>
+                <a:ea typeface="Google Sans Flex"/>
+                <a:cs typeface="Google Sans Flex"/>
+              </a:defRPr>
+            </a:lvl2pPr>
+            <a:lvl3pPr algn="ctr">
+              <a:defRPr sz="1200">
+                <a:solidFill>
+                  <a:srgbClr val="202124"/>
+                </a:solidFill>
+                <a:latin typeface="Google Sans Flex"/>
+                <a:ea typeface="Google Sans Flex"/>
+                <a:cs typeface="Google Sans Flex"/>
+              </a:defRPr>
+            </a:lvl3pPr>
+            <a:lvl4pPr algn="ctr">
+              <a:defRPr sz="1200">
+                <a:solidFill>
+                  <a:srgbClr val="202124"/>
+                </a:solidFill>
+                <a:latin typeface="Google Sans Flex"/>
+                <a:ea typeface="Google Sans Flex"/>
+                <a:cs typeface="Google Sans Flex"/>
+              </a:defRPr>
+            </a:lvl4pPr>
+            <a:lvl5pPr algn="ctr">
+              <a:defRPr sz="1200">
+                <a:solidFill>
+                  <a:srgbClr val="202124"/>
+                </a:solidFill>
+                <a:latin typeface="Google Sans Flex"/>
+                <a:ea typeface="Google Sans Flex"/>
+                <a:cs typeface="Google Sans Flex"/>
+              </a:defRPr>
+            </a:lvl5pPr>
+            <a:lvl6pPr algn="ctr">
+              <a:defRPr sz="1200">
+                <a:solidFill>
+                  <a:srgbClr val="202124"/>
+                </a:solidFill>
+                <a:latin typeface="Google Sans Flex"/>
+                <a:ea typeface="Google Sans Flex"/>
+                <a:cs typeface="Google Sans Flex"/>
+              </a:defRPr>
+            </a:lvl6pPr>
+            <a:lvl7pPr algn="ctr">
+              <a:defRPr sz="1200">
+                <a:solidFill>
+                  <a:srgbClr val="202124"/>
+                </a:solidFill>
+                <a:latin typeface="Google Sans Flex"/>
+                <a:ea typeface="Google Sans Flex"/>
+                <a:cs typeface="Google Sans Flex"/>
+              </a:defRPr>
+            </a:lvl7pPr>
+            <a:lvl8pPr algn="ctr">
+              <a:defRPr sz="1200">
+                <a:solidFill>
+                  <a:srgbClr val="202124"/>
+                </a:solidFill>
+                <a:latin typeface="Google Sans Flex"/>
+                <a:ea typeface="Google Sans Flex"/>
+                <a:cs typeface="Google Sans Flex"/>
+              </a:defRPr>
+            </a:lvl8pPr>
+            <a:lvl9pPr algn="ctr">
+              <a:defRPr sz="1200">
+                <a:solidFill>
+                  <a:srgbClr val="202124"/>
+                </a:solidFill>
+                <a:latin typeface="Google Sans Flex"/>
+                <a:ea typeface="Google Sans Flex"/>
+                <a:cs typeface="Google Sans Flex"/>
+              </a:defRPr>
+            </a:lvl9pPr>
+          </a:lstStyle>
+          <a:p>
+            <a:pPr algn="ctr">
+              <a:defRPr sz="1200">
+                <a:solidFill>
+                  <a:srgbClr val="202124"/>
+                </a:solidFill>
+                <a:latin typeface="Google Sans Flex"/>
+                <a:ea typeface="Google Sans Flex"/>
+                <a:cs typeface="Google Sans Flex"/>
+              </a:defRPr>
+            </a:pPr>
+            <a:r>
+              <a:rPr sz="1200">
+                <a:solidFill>
+                  <a:srgbClr val="202124"/>
+                </a:solidFill>
+                <a:latin typeface="Google Sans Flex"/>
+                <a:ea typeface="Google Sans Flex"/>
+                <a:cs typeface="Google Sans Flex"/>
+              </a:rPr>
+              <a:t>Pay &amp;</a:t>
+            </a:r>
+          </a:p>
+          <a:p>
+            <a:pPr algn="ctr">
+              <a:defRPr sz="1200">
+                <a:solidFill>
+                  <a:srgbClr val="202124"/>
+                </a:solidFill>
+                <a:latin typeface="Google Sans Flex"/>
+                <a:ea typeface="Google Sans Flex"/>
+                <a:cs typeface="Google Sans Flex"/>
+              </a:defRPr>
+            </a:pPr>
+            <a:r>
+              <a:rPr sz="1200">
+                <a:solidFill>
+                  <a:srgbClr val="202124"/>
+                </a:solidFill>
+                <a:latin typeface="Google Sans Flex"/>
+                <a:ea typeface="Google Sans Flex"/>
+                <a:cs typeface="Google Sans Flex"/>
+              </a:rPr>
+              <a:t>generate</a:t>
+            </a:r>
+          </a:p>
+        </p:txBody>
+      </p:sp>
+      <p:sp>
+        <p:nvSpPr>
+          <p:cNvPr id="112" name="Gprime flow 6: Clip second look">
+            <a:extLst>
+              <a:ext uri="{FF2B5EF4-FFF2-40B4-BE49-F238E27FC236}">
+                <a16:creationId xmlns:a16="http://schemas.microsoft.com/office/drawing/2014/main" id="{B96947FC-4FB8-4186-A1B7-3FB957050587}"/>
+              </a:ext>
+            </a:extLst>
+          </p:cNvPr>
+          <p:cNvSpPr>
+            <a:spLocks noGrp="1"/>
+          </p:cNvSpPr>
+          <p:nvPr/>
+        </p:nvSpPr>
+        <p:spPr>
+          <a:xfrm>
+            <a:off x="7461504" y="1572768"/>
+            <a:ext cx="1289304" cy="932688"/>
+          </a:xfrm>
+          <a:prstGeom prst="rect">
+            <a:avLst/>
+          </a:prstGeom>
+          <a:solidFill>
+            <a:srgbClr val="F8F9FA"/>
+          </a:solidFill>
+          <a:ln w="12700">
+            <a:solidFill>
+              <a:srgbClr val="BDC1C6"/>
+            </a:solidFill>
+            <a:prstDash val="solid"/>
+          </a:ln>
+        </p:spPr>
+        <p:txBody>
+          <a:bodyPr lIns="38100" tIns="57150" rIns="38100" bIns="57150" anchor="ctr"/>
+          <a:lstStyle>
+            <a:defPPr algn="ctr">
+              <a:defRPr sz="1200">
+                <a:solidFill>
+                  <a:srgbClr val="202124"/>
+                </a:solidFill>
+                <a:latin typeface="Google Sans Flex"/>
+                <a:ea typeface="Google Sans Flex"/>
+                <a:cs typeface="Google Sans Flex"/>
+              </a:defRPr>
+            </a:defPPr>
+            <a:lvl1pPr algn="ctr">
+              <a:defRPr sz="1200">
+                <a:solidFill>
+                  <a:srgbClr val="202124"/>
+                </a:solidFill>
+                <a:latin typeface="Google Sans Flex"/>
+                <a:ea typeface="Google Sans Flex"/>
+                <a:cs typeface="Google Sans Flex"/>
+              </a:defRPr>
+            </a:lvl1pPr>
+            <a:lvl2pPr algn="ctr">
+              <a:defRPr sz="1200">
+                <a:solidFill>
+                  <a:srgbClr val="202124"/>
+                </a:solidFill>
+                <a:latin typeface="Google Sans Flex"/>
+                <a:ea typeface="Google Sans Flex"/>
+                <a:cs typeface="Google Sans Flex"/>
+              </a:defRPr>
+            </a:lvl2pPr>
+            <a:lvl3pPr algn="ctr">
+              <a:defRPr sz="1200">
+                <a:solidFill>
+                  <a:srgbClr val="202124"/>
+                </a:solidFill>
+                <a:latin typeface="Google Sans Flex"/>
+                <a:ea typeface="Google Sans Flex"/>
+                <a:cs typeface="Google Sans Flex"/>
+              </a:defRPr>
+            </a:lvl3pPr>
+            <a:lvl4pPr algn="ctr">
+              <a:defRPr sz="1200">
+                <a:solidFill>
+                  <a:srgbClr val="202124"/>
+                </a:solidFill>
+                <a:latin typeface="Google Sans Flex"/>
+                <a:ea typeface="Google Sans Flex"/>
+                <a:cs typeface="Google Sans Flex"/>
+              </a:defRPr>
+            </a:lvl4pPr>
+            <a:lvl5pPr algn="ctr">
+              <a:defRPr sz="1200">
+                <a:solidFill>
+                  <a:srgbClr val="202124"/>
+                </a:solidFill>
+                <a:latin typeface="Google Sans Flex"/>
+                <a:ea typeface="Google Sans Flex"/>
+                <a:cs typeface="Google Sans Flex"/>
+              </a:defRPr>
+            </a:lvl5pPr>
+            <a:lvl6pPr algn="ctr">
+              <a:defRPr sz="1200">
+                <a:solidFill>
+                  <a:srgbClr val="202124"/>
+                </a:solidFill>
+                <a:latin typeface="Google Sans Flex"/>
+                <a:ea typeface="Google Sans Flex"/>
+                <a:cs typeface="Google Sans Flex"/>
+              </a:defRPr>
+            </a:lvl6pPr>
+            <a:lvl7pPr algn="ctr">
+              <a:defRPr sz="1200">
+                <a:solidFill>
+                  <a:srgbClr val="202124"/>
+                </a:solidFill>
+                <a:latin typeface="Google Sans Flex"/>
+                <a:ea typeface="Google Sans Flex"/>
+                <a:cs typeface="Google Sans Flex"/>
+              </a:defRPr>
+            </a:lvl7pPr>
+            <a:lvl8pPr algn="ctr">
+              <a:defRPr sz="1200">
+                <a:solidFill>
+                  <a:srgbClr val="202124"/>
+                </a:solidFill>
+                <a:latin typeface="Google Sans Flex"/>
+                <a:ea typeface="Google Sans Flex"/>
+                <a:cs typeface="Google Sans Flex"/>
+              </a:defRPr>
+            </a:lvl8pPr>
+            <a:lvl9pPr algn="ctr">
+              <a:defRPr sz="1200">
+                <a:solidFill>
+                  <a:srgbClr val="202124"/>
+                </a:solidFill>
+                <a:latin typeface="Google Sans Flex"/>
+                <a:ea typeface="Google Sans Flex"/>
+                <a:cs typeface="Google Sans Flex"/>
+              </a:defRPr>
+            </a:lvl9pPr>
+          </a:lstStyle>
+          <a:p>
+            <a:pPr algn="ctr">
+              <a:defRPr sz="1200">
+                <a:solidFill>
+                  <a:srgbClr val="202124"/>
+                </a:solidFill>
+                <a:latin typeface="Google Sans Flex"/>
+                <a:ea typeface="Google Sans Flex"/>
+                <a:cs typeface="Google Sans Flex"/>
+              </a:defRPr>
+            </a:pPr>
+            <a:r>
+              <a:rPr sz="1200">
+                <a:solidFill>
+                  <a:srgbClr val="202124"/>
+                </a:solidFill>
+                <a:latin typeface="Google Sans Flex"/>
+                <a:ea typeface="Google Sans Flex"/>
+                <a:cs typeface="Google Sans Flex"/>
+              </a:rPr>
+              <a:t>Clip</a:t>
+            </a:r>
+          </a:p>
+          <a:p>
+            <a:pPr algn="ctr">
+              <a:defRPr sz="1200">
+                <a:solidFill>
+                  <a:srgbClr val="202124"/>
+                </a:solidFill>
+                <a:latin typeface="Google Sans Flex"/>
+                <a:ea typeface="Google Sans Flex"/>
+                <a:cs typeface="Google Sans Flex"/>
+              </a:defRPr>
+            </a:pPr>
+            <a:r>
+              <a:rPr sz="1200">
+                <a:solidFill>
+                  <a:srgbClr val="202124"/>
+                </a:solidFill>
+                <a:latin typeface="Google Sans Flex"/>
+                <a:ea typeface="Google Sans Flex"/>
+                <a:cs typeface="Google Sans Flex"/>
+              </a:rPr>
+              <a:t>second look</a:t>
+            </a:r>
+          </a:p>
+        </p:txBody>
+      </p:sp>
+      <p:sp>
+        <p:nvSpPr>
+          <p:cNvPr id="113" name="Gprime orange Preflight bracket spanning first four stages">
+            <a:extLst>
+              <a:ext uri="{FF2B5EF4-FFF2-40B4-BE49-F238E27FC236}">
+                <a16:creationId xmlns:a16="http://schemas.microsoft.com/office/drawing/2014/main" id="{7EE7977C-AD70-4820-8785-8441222A6933}"/>
+              </a:ext>
+            </a:extLst>
+          </p:cNvPr>
+          <p:cNvSpPr>
+            <a:spLocks noGrp="1"/>
+          </p:cNvSpPr>
+          <p:nvPr/>
+        </p:nvSpPr>
+        <p:spPr>
+          <a:xfrm>
+            <a:off x="393192" y="2560320"/>
+            <a:ext cx="5477256" cy="146304"/>
+          </a:xfrm>
+          <a:custGeom>
+            <a:pathLst>
+              <a:path w="5477256" h="146304">
+                <a:moveTo>
+                  <a:pt x="0" y="0"/>
+                </a:moveTo>
+                <a:lnTo>
+                  <a:pt x="0" y="146304"/>
+                </a:lnTo>
+                <a:lnTo>
+                  <a:pt x="5477256" y="146304"/>
+                </a:lnTo>
+                <a:lnTo>
+                  <a:pt x="5477256" y="0"/>
+                </a:lnTo>
+              </a:path>
+            </a:pathLst>
+          </a:custGeom>
+          <a:noFill/>
+          <a:ln w="19050">
+            <a:solidFill>
+              <a:srgbClr val="EF7F60"/>
+            </a:solidFill>
+            <a:prstDash val="solid"/>
+          </a:ln>
+        </p:spPr>
+      </p:sp>
+      <p:sp>
+        <p:nvSpPr>
+          <p:cNvPr id="114" name="Gprime Preflight before pay label">
+            <a:extLst>
+              <a:ext uri="{FF2B5EF4-FFF2-40B4-BE49-F238E27FC236}">
+                <a16:creationId xmlns:a16="http://schemas.microsoft.com/office/drawing/2014/main" id="{8A7B0238-33E4-4AC0-BB13-6D43FA5F440B}"/>
+              </a:ext>
+            </a:extLst>
+          </p:cNvPr>
+          <p:cNvSpPr>
+            <a:spLocks noGrp="1"/>
+          </p:cNvSpPr>
+          <p:nvPr/>
+        </p:nvSpPr>
+        <p:spPr>
+          <a:xfrm>
+            <a:off x="393192" y="2761488"/>
+            <a:ext cx="5477256" cy="274320"/>
+          </a:xfrm>
+          <a:prstGeom prst="rect">
+            <a:avLst/>
+          </a:prstGeom>
+          <a:noFill/>
+          <a:ln w="0">
+            <a:noFill/>
+          </a:ln>
+        </p:spPr>
+        <p:txBody>
+          <a:bodyPr lIns="0" tIns="0" rIns="0" bIns="0"/>
+          <a:lstStyle>
+            <a:defPPr algn="ctr">
+              <a:defRPr sz="1300" b="1">
+                <a:solidFill>
+                  <a:srgbClr val="B4563B"/>
+                </a:solidFill>
+                <a:latin typeface="Google Sans Flex"/>
+                <a:ea typeface="Google Sans Flex"/>
+                <a:cs typeface="Google Sans Flex"/>
+              </a:defRPr>
+            </a:defPPr>
+            <a:lvl1pPr algn="ctr">
+              <a:defRPr sz="1300" b="1">
+                <a:solidFill>
+                  <a:srgbClr val="B4563B"/>
+                </a:solidFill>
+                <a:latin typeface="Google Sans Flex"/>
+                <a:ea typeface="Google Sans Flex"/>
+                <a:cs typeface="Google Sans Flex"/>
+              </a:defRPr>
+            </a:lvl1pPr>
+            <a:lvl2pPr algn="ctr">
+              <a:defRPr sz="1300" b="1">
+                <a:solidFill>
+                  <a:srgbClr val="B4563B"/>
+                </a:solidFill>
+                <a:latin typeface="Google Sans Flex"/>
+                <a:ea typeface="Google Sans Flex"/>
+                <a:cs typeface="Google Sans Flex"/>
+              </a:defRPr>
+            </a:lvl2pPr>
+            <a:lvl3pPr algn="ctr">
+              <a:defRPr sz="1300" b="1">
+                <a:solidFill>
+                  <a:srgbClr val="B4563B"/>
+                </a:solidFill>
+                <a:latin typeface="Google Sans Flex"/>
+                <a:ea typeface="Google Sans Flex"/>
+                <a:cs typeface="Google Sans Flex"/>
+              </a:defRPr>
+            </a:lvl3pPr>
+            <a:lvl4pPr algn="ctr">
+              <a:defRPr sz="1300" b="1">
+                <a:solidFill>
+                  <a:srgbClr val="B4563B"/>
+                </a:solidFill>
+                <a:latin typeface="Google Sans Flex"/>
+                <a:ea typeface="Google Sans Flex"/>
+                <a:cs typeface="Google Sans Flex"/>
+              </a:defRPr>
+            </a:lvl4pPr>
+            <a:lvl5pPr algn="ctr">
+              <a:defRPr sz="1300" b="1">
+                <a:solidFill>
+                  <a:srgbClr val="B4563B"/>
+                </a:solidFill>
+                <a:latin typeface="Google Sans Flex"/>
+                <a:ea typeface="Google Sans Flex"/>
+                <a:cs typeface="Google Sans Flex"/>
+              </a:defRPr>
+            </a:lvl5pPr>
+            <a:lvl6pPr algn="ctr">
+              <a:defRPr sz="1300" b="1">
+                <a:solidFill>
+                  <a:srgbClr val="B4563B"/>
+                </a:solidFill>
+                <a:latin typeface="Google Sans Flex"/>
+                <a:ea typeface="Google Sans Flex"/>
+                <a:cs typeface="Google Sans Flex"/>
+              </a:defRPr>
+            </a:lvl6pPr>
+            <a:lvl7pPr algn="ctr">
+              <a:defRPr sz="1300" b="1">
+                <a:solidFill>
+                  <a:srgbClr val="B4563B"/>
+                </a:solidFill>
+                <a:latin typeface="Google Sans Flex"/>
+                <a:ea typeface="Google Sans Flex"/>
+                <a:cs typeface="Google Sans Flex"/>
+              </a:defRPr>
+            </a:lvl7pPr>
+            <a:lvl8pPr algn="ctr">
+              <a:defRPr sz="1300" b="1">
+                <a:solidFill>
+                  <a:srgbClr val="B4563B"/>
+                </a:solidFill>
+                <a:latin typeface="Google Sans Flex"/>
+                <a:ea typeface="Google Sans Flex"/>
+                <a:cs typeface="Google Sans Flex"/>
+              </a:defRPr>
+            </a:lvl8pPr>
+            <a:lvl9pPr algn="ctr">
+              <a:defRPr sz="1300" b="1">
+                <a:solidFill>
+                  <a:srgbClr val="B4563B"/>
+                </a:solidFill>
+                <a:latin typeface="Google Sans Flex"/>
+                <a:ea typeface="Google Sans Flex"/>
+                <a:cs typeface="Google Sans Flex"/>
+              </a:defRPr>
+            </a:lvl9pPr>
+          </a:lstStyle>
+          <a:p>
+            <a:pPr algn="ctr">
+              <a:defRPr sz="1300" b="1">
+                <a:solidFill>
+                  <a:srgbClr val="B4563B"/>
+                </a:solidFill>
+                <a:latin typeface="Google Sans Flex"/>
+                <a:ea typeface="Google Sans Flex"/>
+                <a:cs typeface="Google Sans Flex"/>
+              </a:defRPr>
+            </a:pPr>
+            <a:r>
+              <a:rPr sz="1300" b="1">
+                <a:solidFill>
+                  <a:srgbClr val="B4563B"/>
+                </a:solidFill>
+                <a:latin typeface="Google Sans Flex"/>
+                <a:ea typeface="Google Sans Flex"/>
+                <a:cs typeface="Google Sans Flex"/>
+              </a:rPr>
+              <a:t>Preflight · before "pay"</a:t>
             </a:r>
           </a:p>
         </p:txBody>

</xml_diff>

<commit_message>
Update submission deck to verified v7 demo
</commit_message>
<xml_diff>
--- a/docs/Preflight_pitch_deck.pptx
+++ b/docs/Preflight_pitch_deck.pptx
@@ -9400,29 +9400,6 @@
               <a:t>Non-English vote data before scoring non-English prompts.</a:t>
             </a:r>
           </a:p>
-          <a:p>
-            <a:pPr algn="l" marL="0" indent="0">
-              <a:lnSpc>
-                <a:spcPct val="108000"/>
-              </a:lnSpc>
-              <a:spcAft>
-                <a:spcPts val="1600"/>
-              </a:spcAft>
-              <a:buNone/>
-            </a:pPr>
-            <a:r>
-              <a:rPr lang="en-US" sz="1600" b="0">
-                <a:solidFill>
-                  <a:srgbClr val="202124"/>
-                </a:solidFill>
-                <a:latin typeface="Google Sans Flex"/>
-                <a:ea typeface="Google Sans Flex"/>
-                <a:cs typeface="Google Sans Flex"/>
-                <a:sym typeface="Google Sans Flex"/>
-              </a:rPr>
-              <a:t>On-page emphasis of the risk drop.</a:t>
-            </a:r>
-          </a:p>
         </p:txBody>
       </p:sp>
     </p:spTree>
@@ -9715,7 +9692,7 @@
                 <a:sym typeface="Google Sans Flex"/>
                 <a:hlinkClick r:id="rIdVideoFinal"/>
               </a:rPr>
-              <a:t>https://youtu.be/nO-J4-5G-Gs</a:t>
+              <a:t>https://youtu.be/1A8I-9NZ3Kc</a:t>
             </a:r>
           </a:p>
           <a:p>

</xml_diff>